<commit_message>
Présentation complète : retour à l'ancienne page de couverture
Co-Authored-By: Claude Sonnet 5.5 <noreply@anthropic.com>
</commit_message>
<xml_diff>
--- a/docs/rapports/Presentation-ImmoBell-Complete.pptx
+++ b/docs/rapports/Presentation-ImmoBell-Complete.pptx
@@ -6762,7 +6762,7 @@
         <p:spPr>
           <a:xfrm>
             <a:off x="812800" y="2032000"/>
-            <a:ext cx="10160000" cy="1524000"/>
+            <a:ext cx="9906000" cy="2540000"/>
           </a:xfrm>
           <a:prstGeom prst="rect">
             <a:avLst/>
@@ -6800,13 +6800,13 @@
               </a:spcAft>
             </a:pPr>
             <a:r>
-              <a:rPr sz="5500" b="1">
+              <a:rPr sz="6000" b="1">
                 <a:solidFill>
                   <a:srgbClr val="F4EFE2"/>
                 </a:solidFill>
                 <a:latin typeface="Arial"/>
               </a:rPr>
-              <a:t>Synthèse de direction</a:t>
+              <a:t>Un nom de prestige, une gestion d’excellence</a:t>
             </a:r>
           </a:p>
         </p:txBody>
@@ -6819,8 +6819,8 @@
         </p:nvSpPr>
         <p:spPr>
           <a:xfrm>
-            <a:off x="812800" y="3556000"/>
-            <a:ext cx="9906000" cy="825500"/>
+            <a:off x="812800" y="4826000"/>
+            <a:ext cx="9525000" cy="762000"/>
           </a:xfrm>
           <a:prstGeom prst="rect">
             <a:avLst/>
@@ -6855,13 +6855,13 @@
               </a:spcAft>
             </a:pPr>
             <a:r>
-              <a:rPr sz="2000" b="0">
+              <a:rPr sz="2200" b="0">
                 <a:solidFill>
                   <a:srgbClr val="BDB6A3"/>
                 </a:solidFill>
                 <a:latin typeface="Arial"/>
               </a:rPr>
-              <a:t>Cinq pôles, une même chaîne : offrir, faire connaître, sécuriser, suivre et livrer.</a:t>
+              <a:t>Gestion locative et services immobiliers à Bonanjo, Douala</a:t>
             </a:r>
           </a:p>
         </p:txBody>
@@ -6874,8 +6874,8 @@
         </p:nvSpPr>
         <p:spPr>
           <a:xfrm>
-            <a:off x="812800" y="4826000"/>
-            <a:ext cx="2413000" cy="1143000"/>
+            <a:off x="812800" y="5969000"/>
+            <a:ext cx="7620000" cy="254000"/>
           </a:xfrm>
           <a:prstGeom prst="rect">
             <a:avLst/>
@@ -6910,297 +6910,13 @@
               </a:spcAft>
             </a:pPr>
             <a:r>
-              <a:rPr sz="4000" b="1">
-                <a:solidFill>
-                  <a:srgbClr val="F2B000"/>
+              <a:rPr sz="1200" b="0">
+                <a:solidFill>
+                  <a:srgbClr val="BDB6A3"/>
                 </a:solidFill>
                 <a:latin typeface="Arial"/>
               </a:rPr>
-              <a:t>100</a:t>
-            </a:r>
-          </a:p>
-          <a:p>
-            <a:pPr algn="l">
-              <a:spcAft>
-                <a:spcPts val="0"/>
-              </a:spcAft>
-            </a:pPr>
-            <a:r>
-              <a:rPr sz="1400" b="0">
-                <a:solidFill>
-                  <a:srgbClr val="BDB6A3"/>
-                </a:solidFill>
-                <a:latin typeface="Arial"/>
-              </a:rPr>
-              <a:t>contrats</a:t>
-            </a:r>
-          </a:p>
-        </p:txBody>
-      </p:sp>
-      <p:sp>
-        <p:nvSpPr>
-          <p:cNvPr id="7" name="Rectangle 6"/>
-          <p:cNvSpPr/>
-          <p:nvPr/>
-        </p:nvSpPr>
-        <p:spPr>
-          <a:xfrm>
-            <a:off x="3479800" y="4826000"/>
-            <a:ext cx="2413000" cy="1143000"/>
-          </a:xfrm>
-          <a:prstGeom prst="rect">
-            <a:avLst/>
-          </a:prstGeom>
-          <a:noFill/>
-          <a:ln>
-            <a:noFill/>
-          </a:ln>
-          <a:effectLst/>
-        </p:spPr>
-        <p:style>
-          <a:lnRef idx="1">
-            <a:schemeClr val="accent1"/>
-          </a:lnRef>
-          <a:fillRef idx="3">
-            <a:schemeClr val="accent1"/>
-          </a:fillRef>
-          <a:effectRef idx="2">
-            <a:schemeClr val="accent1"/>
-          </a:effectRef>
-          <a:fontRef idx="minor">
-            <a:schemeClr val="lt1"/>
-          </a:fontRef>
-        </p:style>
-        <p:txBody>
-          <a:bodyPr rtlCol="0" anchor="t" wrap="square" lIns="0" rIns="0" tIns="0" bIns="0"/>
-          <a:lstStyle/>
-          <a:p>
-            <a:pPr algn="l">
-              <a:spcAft>
-                <a:spcPts val="0"/>
-              </a:spcAft>
-            </a:pPr>
-            <a:r>
-              <a:rPr sz="4000" b="1">
-                <a:solidFill>
-                  <a:srgbClr val="F2B000"/>
-                </a:solidFill>
-                <a:latin typeface="Arial"/>
-              </a:rPr>
-              <a:t>50 M</a:t>
-            </a:r>
-          </a:p>
-          <a:p>
-            <a:pPr algn="l">
-              <a:spcAft>
-                <a:spcPts val="0"/>
-              </a:spcAft>
-            </a:pPr>
-            <a:r>
-              <a:rPr sz="1400" b="0">
-                <a:solidFill>
-                  <a:srgbClr val="BDB6A3"/>
-                </a:solidFill>
-                <a:latin typeface="Arial"/>
-              </a:rPr>
-              <a:t>FCFA visés</a:t>
-            </a:r>
-          </a:p>
-        </p:txBody>
-      </p:sp>
-      <p:sp>
-        <p:nvSpPr>
-          <p:cNvPr id="8" name="Rectangle 7"/>
-          <p:cNvSpPr/>
-          <p:nvPr/>
-        </p:nvSpPr>
-        <p:spPr>
-          <a:xfrm>
-            <a:off x="6146800" y="4826000"/>
-            <a:ext cx="2413000" cy="1143000"/>
-          </a:xfrm>
-          <a:prstGeom prst="rect">
-            <a:avLst/>
-          </a:prstGeom>
-          <a:noFill/>
-          <a:ln>
-            <a:noFill/>
-          </a:ln>
-          <a:effectLst/>
-        </p:spPr>
-        <p:style>
-          <a:lnRef idx="1">
-            <a:schemeClr val="accent1"/>
-          </a:lnRef>
-          <a:fillRef idx="3">
-            <a:schemeClr val="accent1"/>
-          </a:fillRef>
-          <a:effectRef idx="2">
-            <a:schemeClr val="accent1"/>
-          </a:effectRef>
-          <a:fontRef idx="minor">
-            <a:schemeClr val="lt1"/>
-          </a:fontRef>
-        </p:style>
-        <p:txBody>
-          <a:bodyPr rtlCol="0" anchor="t" wrap="square" lIns="0" rIns="0" tIns="0" bIns="0"/>
-          <a:lstStyle/>
-          <a:p>
-            <a:pPr algn="l">
-              <a:spcAft>
-                <a:spcPts val="0"/>
-              </a:spcAft>
-            </a:pPr>
-            <a:r>
-              <a:rPr sz="4000" b="1">
-                <a:solidFill>
-                  <a:srgbClr val="F2B000"/>
-                </a:solidFill>
-                <a:latin typeface="Arial"/>
-              </a:rPr>
-              <a:t>0 F</a:t>
-            </a:r>
-          </a:p>
-          <a:p>
-            <a:pPr algn="l">
-              <a:spcAft>
-                <a:spcPts val="0"/>
-              </a:spcAft>
-            </a:pPr>
-            <a:r>
-              <a:rPr sz="1400" b="0">
-                <a:solidFill>
-                  <a:srgbClr val="BDB6A3"/>
-                </a:solidFill>
-                <a:latin typeface="Arial"/>
-              </a:rPr>
-              <a:t>de publicité</a:t>
-            </a:r>
-          </a:p>
-        </p:txBody>
-      </p:sp>
-      <p:sp>
-        <p:nvSpPr>
-          <p:cNvPr id="9" name="Rectangle 8"/>
-          <p:cNvSpPr/>
-          <p:nvPr/>
-        </p:nvSpPr>
-        <p:spPr>
-          <a:xfrm>
-            <a:off x="8813800" y="4826000"/>
-            <a:ext cx="2413000" cy="1143000"/>
-          </a:xfrm>
-          <a:prstGeom prst="rect">
-            <a:avLst/>
-          </a:prstGeom>
-          <a:noFill/>
-          <a:ln>
-            <a:noFill/>
-          </a:ln>
-          <a:effectLst/>
-        </p:spPr>
-        <p:style>
-          <a:lnRef idx="1">
-            <a:schemeClr val="accent1"/>
-          </a:lnRef>
-          <a:fillRef idx="3">
-            <a:schemeClr val="accent1"/>
-          </a:fillRef>
-          <a:effectRef idx="2">
-            <a:schemeClr val="accent1"/>
-          </a:effectRef>
-          <a:fontRef idx="minor">
-            <a:schemeClr val="lt1"/>
-          </a:fontRef>
-        </p:style>
-        <p:txBody>
-          <a:bodyPr rtlCol="0" anchor="t" wrap="square" lIns="0" rIns="0" tIns="0" bIns="0"/>
-          <a:lstStyle/>
-          <a:p>
-            <a:pPr algn="l">
-              <a:spcAft>
-                <a:spcPts val="0"/>
-              </a:spcAft>
-            </a:pPr>
-            <a:r>
-              <a:rPr sz="4000" b="1">
-                <a:solidFill>
-                  <a:srgbClr val="F2B000"/>
-                </a:solidFill>
-                <a:latin typeface="Arial"/>
-              </a:rPr>
-              <a:t>5</a:t>
-            </a:r>
-          </a:p>
-          <a:p>
-            <a:pPr algn="l">
-              <a:spcAft>
-                <a:spcPts val="0"/>
-              </a:spcAft>
-            </a:pPr>
-            <a:r>
-              <a:rPr sz="1400" b="0">
-                <a:solidFill>
-                  <a:srgbClr val="BDB6A3"/>
-                </a:solidFill>
-                <a:latin typeface="Arial"/>
-              </a:rPr>
-              <a:t>pôles</a:t>
-            </a:r>
-          </a:p>
-        </p:txBody>
-      </p:sp>
-      <p:sp>
-        <p:nvSpPr>
-          <p:cNvPr id="10" name="Rectangle 9"/>
-          <p:cNvSpPr/>
-          <p:nvPr/>
-        </p:nvSpPr>
-        <p:spPr>
-          <a:xfrm>
-            <a:off x="6985000" y="6248400"/>
-            <a:ext cx="4445000" cy="254000"/>
-          </a:xfrm>
-          <a:prstGeom prst="rect">
-            <a:avLst/>
-          </a:prstGeom>
-          <a:noFill/>
-          <a:ln>
-            <a:noFill/>
-          </a:ln>
-          <a:effectLst/>
-        </p:spPr>
-        <p:style>
-          <a:lnRef idx="1">
-            <a:schemeClr val="accent1"/>
-          </a:lnRef>
-          <a:fillRef idx="3">
-            <a:schemeClr val="accent1"/>
-          </a:fillRef>
-          <a:effectRef idx="2">
-            <a:schemeClr val="accent1"/>
-          </a:effectRef>
-          <a:fontRef idx="minor">
-            <a:schemeClr val="lt1"/>
-          </a:fontRef>
-        </p:style>
-        <p:txBody>
-          <a:bodyPr rtlCol="0" anchor="t" wrap="square" lIns="0" rIns="0" tIns="0" bIns="0"/>
-          <a:lstStyle/>
-          <a:p>
-            <a:pPr algn="l">
-              <a:spcAft>
-                <a:spcPts val="0"/>
-              </a:spcAft>
-            </a:pPr>
-            <a:r>
-              <a:rPr sz="1200" b="0">
-                <a:solidFill>
-                  <a:srgbClr val="BDB6A3"/>
-                </a:solidFill>
-                <a:latin typeface="Arial"/>
-              </a:rPr>
-              <a:t>OCTOBRE 2026</a:t>
+              <a:t>Présentation aux investisseurs · Octobre 2026</a:t>
             </a:r>
           </a:p>
         </p:txBody>
@@ -7413,7 +7129,7 @@
                             </p:stCondLst>
                             <p:childTnLst>
                               <p:par>
-                                <p:cTn id="23" presetID="22" presetClass="entr" presetSubtype="4" fill="hold" grpId="0" nodeType="afterEffect">
+                                <p:cTn id="23" presetID="10" presetClass="entr" presetSubtype="0" fill="hold" grpId="0" nodeType="afterEffect">
                                   <p:stCondLst>
                                     <p:cond delay="0"/>
                                   </p:stCondLst>
@@ -7436,187 +7152,11 @@
                                         <p:strVal val="visible"/>
                                       </p:to>
                                     </p:set>
-                                    <p:animEffect transition="in" filter="wipe(down)">
+                                    <p:animEffect transition="in" filter="fade">
                                       <p:cBhvr>
                                         <p:cTn id="22" dur="500"/>
                                         <p:tgtEl>
                                           <p:spTgt spid="6"/>
-                                        </p:tgtEl>
-                                      </p:cBhvr>
-                                    </p:animEffect>
-                                  </p:childTnLst>
-                                </p:cTn>
-                              </p:par>
-                            </p:childTnLst>
-                          </p:cTn>
-                        </p:par>
-                        <p:par>
-                          <p:cTn id="24" fill="hold">
-                            <p:stCondLst>
-                              <p:cond delay="2500"/>
-                            </p:stCondLst>
-                            <p:childTnLst>
-                              <p:par>
-                                <p:cTn id="27" presetID="22" presetClass="entr" presetSubtype="4" fill="hold" grpId="0" nodeType="afterEffect">
-                                  <p:stCondLst>
-                                    <p:cond delay="0"/>
-                                  </p:stCondLst>
-                                  <p:childTnLst>
-                                    <p:set>
-                                      <p:cBhvr>
-                                        <p:cTn id="25" dur="1" fill="hold">
-                                          <p:stCondLst>
-                                            <p:cond delay="0"/>
-                                          </p:stCondLst>
-                                        </p:cTn>
-                                        <p:tgtEl>
-                                          <p:spTgt spid="7"/>
-                                        </p:tgtEl>
-                                        <p:attrNameLst>
-                                          <p:attrName>style.visibility</p:attrName>
-                                        </p:attrNameLst>
-                                      </p:cBhvr>
-                                      <p:to>
-                                        <p:strVal val="visible"/>
-                                      </p:to>
-                                    </p:set>
-                                    <p:animEffect transition="in" filter="wipe(down)">
-                                      <p:cBhvr>
-                                        <p:cTn id="26" dur="500"/>
-                                        <p:tgtEl>
-                                          <p:spTgt spid="7"/>
-                                        </p:tgtEl>
-                                      </p:cBhvr>
-                                    </p:animEffect>
-                                  </p:childTnLst>
-                                </p:cTn>
-                              </p:par>
-                            </p:childTnLst>
-                          </p:cTn>
-                        </p:par>
-                        <p:par>
-                          <p:cTn id="28" fill="hold">
-                            <p:stCondLst>
-                              <p:cond delay="3000"/>
-                            </p:stCondLst>
-                            <p:childTnLst>
-                              <p:par>
-                                <p:cTn id="31" presetID="22" presetClass="entr" presetSubtype="4" fill="hold" grpId="0" nodeType="afterEffect">
-                                  <p:stCondLst>
-                                    <p:cond delay="0"/>
-                                  </p:stCondLst>
-                                  <p:childTnLst>
-                                    <p:set>
-                                      <p:cBhvr>
-                                        <p:cTn id="29" dur="1" fill="hold">
-                                          <p:stCondLst>
-                                            <p:cond delay="0"/>
-                                          </p:stCondLst>
-                                        </p:cTn>
-                                        <p:tgtEl>
-                                          <p:spTgt spid="8"/>
-                                        </p:tgtEl>
-                                        <p:attrNameLst>
-                                          <p:attrName>style.visibility</p:attrName>
-                                        </p:attrNameLst>
-                                      </p:cBhvr>
-                                      <p:to>
-                                        <p:strVal val="visible"/>
-                                      </p:to>
-                                    </p:set>
-                                    <p:animEffect transition="in" filter="wipe(down)">
-                                      <p:cBhvr>
-                                        <p:cTn id="30" dur="500"/>
-                                        <p:tgtEl>
-                                          <p:spTgt spid="8"/>
-                                        </p:tgtEl>
-                                      </p:cBhvr>
-                                    </p:animEffect>
-                                  </p:childTnLst>
-                                </p:cTn>
-                              </p:par>
-                            </p:childTnLst>
-                          </p:cTn>
-                        </p:par>
-                        <p:par>
-                          <p:cTn id="32" fill="hold">
-                            <p:stCondLst>
-                              <p:cond delay="3500"/>
-                            </p:stCondLst>
-                            <p:childTnLst>
-                              <p:par>
-                                <p:cTn id="35" presetID="22" presetClass="entr" presetSubtype="4" fill="hold" grpId="0" nodeType="afterEffect">
-                                  <p:stCondLst>
-                                    <p:cond delay="0"/>
-                                  </p:stCondLst>
-                                  <p:childTnLst>
-                                    <p:set>
-                                      <p:cBhvr>
-                                        <p:cTn id="33" dur="1" fill="hold">
-                                          <p:stCondLst>
-                                            <p:cond delay="0"/>
-                                          </p:stCondLst>
-                                        </p:cTn>
-                                        <p:tgtEl>
-                                          <p:spTgt spid="9"/>
-                                        </p:tgtEl>
-                                        <p:attrNameLst>
-                                          <p:attrName>style.visibility</p:attrName>
-                                        </p:attrNameLst>
-                                      </p:cBhvr>
-                                      <p:to>
-                                        <p:strVal val="visible"/>
-                                      </p:to>
-                                    </p:set>
-                                    <p:animEffect transition="in" filter="wipe(down)">
-                                      <p:cBhvr>
-                                        <p:cTn id="34" dur="500"/>
-                                        <p:tgtEl>
-                                          <p:spTgt spid="9"/>
-                                        </p:tgtEl>
-                                      </p:cBhvr>
-                                    </p:animEffect>
-                                  </p:childTnLst>
-                                </p:cTn>
-                              </p:par>
-                            </p:childTnLst>
-                          </p:cTn>
-                        </p:par>
-                        <p:par>
-                          <p:cTn id="36" fill="hold">
-                            <p:stCondLst>
-                              <p:cond delay="4000"/>
-                            </p:stCondLst>
-                            <p:childTnLst>
-                              <p:par>
-                                <p:cTn id="39" presetID="10" presetClass="entr" presetSubtype="0" fill="hold" grpId="0" nodeType="afterEffect">
-                                  <p:stCondLst>
-                                    <p:cond delay="0"/>
-                                  </p:stCondLst>
-                                  <p:childTnLst>
-                                    <p:set>
-                                      <p:cBhvr>
-                                        <p:cTn id="37" dur="1" fill="hold">
-                                          <p:stCondLst>
-                                            <p:cond delay="0"/>
-                                          </p:stCondLst>
-                                        </p:cTn>
-                                        <p:tgtEl>
-                                          <p:spTgt spid="10"/>
-                                        </p:tgtEl>
-                                        <p:attrNameLst>
-                                          <p:attrName>style.visibility</p:attrName>
-                                        </p:attrNameLst>
-                                      </p:cBhvr>
-                                      <p:to>
-                                        <p:strVal val="visible"/>
-                                      </p:to>
-                                    </p:set>
-                                    <p:animEffect transition="in" filter="fade">
-                                      <p:cBhvr>
-                                        <p:cTn id="38" dur="500"/>
-                                        <p:tgtEl>
-                                          <p:spTgt spid="10"/>
                                         </p:tgtEl>
                                       </p:cBhvr>
                                     </p:animEffect>
@@ -7655,10 +7195,6 @@
       <p:bldP spid="4" grpId="0" animBg="1"/>
       <p:bldP spid="5" grpId="0" animBg="1"/>
       <p:bldP spid="6" grpId="0" animBg="1"/>
-      <p:bldP spid="7" grpId="0" animBg="1"/>
-      <p:bldP spid="8" grpId="0" animBg="1"/>
-      <p:bldP spid="9" grpId="0" animBg="1"/>
-      <p:bldP spid="10" grpId="0" animBg="1"/>
     </p:bldLst>
   </p:timing>
 </p:sld>

</xml_diff>